<commit_message>
Show three ways to order a coffee on the Q8 answer slide
Q8 drops its hint. The answer slide lists "Can I have a coffee, please?",
"A coffee, please." and "I'd like a coffee, please.", and the point says
any of them is fine.

Co-Authored-By: Claude Opus 5.5 <noreply@anthropic.com>
Claude-Session: https://claude.ai/code/session_01AdzV2rtokspoPMcfpFKx4K
</commit_message>
<xml_diff>
--- a/matome/articles-4/articles-4-slides.pptx
+++ b/matome/articles-4/articles-4-slides.pptx
@@ -5386,131 +5386,6 @@
           </a:p>
         </p:txBody>
       </p:sp>
-      <p:sp>
-        <p:nvSpPr>
-          <p:cNvPr id="10" name=""/>
-          <p:cNvSpPr/>
-          <p:nvPr/>
-        </p:nvSpPr>
-        <p:spPr>
-          <a:xfrm>
-            <a:off x="685800" y="5324475"/>
-            <a:ext cx="857250" cy="371475"/>
-          </a:xfrm>
-          <a:prstGeom prst="roundRect">
-            <a:avLst>
-              <a:gd name="adj" fmla="val 50000"/>
-            </a:avLst>
-          </a:prstGeom>
-          <a:solidFill>
-            <a:srgbClr val="FFE3D8"/>
-          </a:solidFill>
-          <a:ln/>
-        </p:spPr>
-      </p:sp>
-      <p:sp>
-        <p:nvSpPr>
-          <p:cNvPr id="11" name=""/>
-          <p:cNvSpPr txBox="1"/>
-          <p:nvPr/>
-        </p:nvSpPr>
-        <p:spPr>
-          <a:xfrm>
-            <a:off x="857250" y="5381625"/>
-            <a:ext cx="933450" cy="247650"/>
-          </a:xfrm>
-          <a:prstGeom prst="rect">
-            <a:avLst/>
-          </a:prstGeom>
-          <a:noFill/>
-          <a:ln/>
-        </p:spPr>
-        <p:txBody>
-          <a:bodyPr wrap="square" lIns="0" tIns="0" rIns="0" bIns="0" anchor="ctr"/>
-          <a:lstStyle/>
-          <a:p>
-            <a:pPr/>
-            <a:r>
-              <a:rPr sz="1350" b="1">
-                <a:solidFill>
-                  <a:srgbClr val="C8401A"/>
-                </a:solidFill>
-                <a:latin typeface="Noto Sans JP"/>
-                <a:ea typeface="Noto Sans JP"/>
-              </a:rPr>
-              <a:t>ヒント</a:t>
-            </a:r>
-          </a:p>
-        </p:txBody>
-      </p:sp>
-      <p:sp>
-        <p:nvSpPr>
-          <p:cNvPr id="12" name=""/>
-          <p:cNvSpPr txBox="1"/>
-          <p:nvPr/>
-        </p:nvSpPr>
-        <p:spPr>
-          <a:xfrm>
-            <a:off x="1847850" y="5314950"/>
-            <a:ext cx="3419475" cy="390525"/>
-          </a:xfrm>
-          <a:prstGeom prst="rect">
-            <a:avLst/>
-          </a:prstGeom>
-          <a:noFill/>
-          <a:ln/>
-        </p:spPr>
-        <p:txBody>
-          <a:bodyPr wrap="square" lIns="0" tIns="0" rIns="0" bIns="0" anchor="ctr"/>
-          <a:lstStyle/>
-          <a:p>
-            <a:pPr/>
-            <a:r>
-              <a:rPr sz="2100" b="1">
-                <a:solidFill>
-                  <a:srgbClr val="1C2340"/>
-                </a:solidFill>
-                <a:latin typeface="DM Sans"/>
-                <a:ea typeface="DM Sans"/>
-              </a:rPr>
-              <a:t>Can I have </a:t>
-            </a:r>
-            <a:pPr/>
-            <a:r>
-              <a:rPr sz="2100" b="1">
-                <a:solidFill>
-                  <a:srgbClr val="1C2340"/>
-                </a:solidFill>
-                <a:latin typeface="Noto Sans JP"/>
-                <a:ea typeface="Noto Sans JP"/>
-              </a:rPr>
-              <a:t>〜</a:t>
-            </a:r>
-            <a:pPr/>
-            <a:r>
-              <a:rPr sz="2100" b="1">
-                <a:solidFill>
-                  <a:srgbClr val="1C2340"/>
-                </a:solidFill>
-                <a:latin typeface="DM Sans"/>
-                <a:ea typeface="DM Sans"/>
-              </a:rPr>
-              <a:t>?</a:t>
-            </a:r>
-            <a:pPr/>
-            <a:r>
-              <a:rPr sz="2100" b="1">
-                <a:solidFill>
-                  <a:srgbClr val="1C2340"/>
-                </a:solidFill>
-                <a:latin typeface="Noto Sans JP"/>
-                <a:ea typeface="Noto Sans JP"/>
-              </a:rPr>
-              <a:t> の形で</a:t>
-            </a:r>
-          </a:p>
-        </p:txBody>
-      </p:sp>
     </p:spTree>
   </p:cSld>
   <p:clrMapOvr>
@@ -6726,7 +6601,7 @@
         </p:nvSpPr>
         <p:spPr>
           <a:xfrm>
-            <a:off x="3162300" y="2676525"/>
+            <a:off x="3162300" y="2066925"/>
             <a:ext cx="6181725" cy="495300"/>
           </a:xfrm>
           <a:prstGeom prst="rect">
@@ -6783,7 +6658,110 @@
         </p:nvSpPr>
         <p:spPr>
           <a:xfrm>
-            <a:off x="3162300" y="3333750"/>
+            <a:off x="3162300" y="2676525"/>
+            <a:ext cx="3848100" cy="495300"/>
+          </a:xfrm>
+          <a:prstGeom prst="rect">
+            <a:avLst/>
+          </a:prstGeom>
+          <a:noFill/>
+          <a:ln/>
+        </p:spPr>
+        <p:txBody>
+          <a:bodyPr wrap="square" lIns="0" tIns="0" rIns="0" bIns="0" anchor="ctr"/>
+          <a:lstStyle/>
+          <a:p>
+            <a:pPr/>
+            <a:r>
+              <a:rPr sz="3000" b="1">
+                <a:solidFill>
+                  <a:srgbClr val="E8461E"/>
+                </a:solidFill>
+                <a:latin typeface="DM Sans"/>
+                <a:ea typeface="DM Sans"/>
+              </a:rPr>
+              <a:t>A</a:t>
+            </a:r>
+            <a:pPr/>
+            <a:r>
+              <a:rPr sz="3000" b="1">
+                <a:solidFill>
+                  <a:srgbClr val="1C2340"/>
+                </a:solidFill>
+                <a:latin typeface="DM Sans"/>
+                <a:ea typeface="DM Sans"/>
+              </a:rPr>
+              <a:t> coffee, please.</a:t>
+            </a:r>
+          </a:p>
+        </p:txBody>
+      </p:sp>
+      <p:sp>
+        <p:nvSpPr>
+          <p:cNvPr id="11" name=""/>
+          <p:cNvSpPr txBox="1"/>
+          <p:nvPr/>
+        </p:nvSpPr>
+        <p:spPr>
+          <a:xfrm>
+            <a:off x="3162300" y="3286125"/>
+            <a:ext cx="5191125" cy="495300"/>
+          </a:xfrm>
+          <a:prstGeom prst="rect">
+            <a:avLst/>
+          </a:prstGeom>
+          <a:noFill/>
+          <a:ln/>
+        </p:spPr>
+        <p:txBody>
+          <a:bodyPr wrap="square" lIns="0" tIns="0" rIns="0" bIns="0" anchor="ctr"/>
+          <a:lstStyle/>
+          <a:p>
+            <a:pPr/>
+            <a:r>
+              <a:rPr sz="3000" b="1">
+                <a:solidFill>
+                  <a:srgbClr val="1C2340"/>
+                </a:solidFill>
+                <a:latin typeface="DM Sans"/>
+                <a:ea typeface="DM Sans"/>
+              </a:rPr>
+              <a:t>I'd like </a:t>
+            </a:r>
+            <a:pPr/>
+            <a:r>
+              <a:rPr sz="3000" b="1">
+                <a:solidFill>
+                  <a:srgbClr val="E8461E"/>
+                </a:solidFill>
+                <a:latin typeface="DM Sans"/>
+                <a:ea typeface="DM Sans"/>
+              </a:rPr>
+              <a:t>a</a:t>
+            </a:r>
+            <a:pPr/>
+            <a:r>
+              <a:rPr sz="3000" b="1">
+                <a:solidFill>
+                  <a:srgbClr val="1C2340"/>
+                </a:solidFill>
+                <a:latin typeface="DM Sans"/>
+                <a:ea typeface="DM Sans"/>
+              </a:rPr>
+              <a:t> coffee, please.</a:t>
+            </a:r>
+          </a:p>
+        </p:txBody>
+      </p:sp>
+      <p:sp>
+        <p:nvSpPr>
+          <p:cNvPr id="12" name=""/>
+          <p:cNvSpPr txBox="1"/>
+          <p:nvPr/>
+        </p:nvSpPr>
+        <p:spPr>
+          <a:xfrm>
+            <a:off x="3162300" y="3943350"/>
             <a:ext cx="3133725" cy="304800"/>
           </a:xfrm>
           <a:prstGeom prst="rect">
@@ -6812,7 +6790,7 @@
       </p:sp>
       <p:sp>
         <p:nvSpPr>
-          <p:cNvPr id="11" name=""/>
+          <p:cNvPr id="13" name=""/>
           <p:cNvSpPr/>
           <p:nvPr/>
         </p:nvSpPr>
@@ -6834,7 +6812,7 @@
       </p:sp>
       <p:sp>
         <p:nvSpPr>
-          <p:cNvPr id="12" name=""/>
+          <p:cNvPr id="14" name=""/>
           <p:cNvSpPr/>
           <p:nvPr/>
         </p:nvSpPr>
@@ -6856,7 +6834,7 @@
       </p:sp>
       <p:sp>
         <p:nvSpPr>
-          <p:cNvPr id="13" name=""/>
+          <p:cNvPr id="15" name=""/>
           <p:cNvSpPr txBox="1"/>
           <p:nvPr/>
         </p:nvSpPr>
@@ -6891,14 +6869,14 @@
       </p:sp>
       <p:sp>
         <p:nvSpPr>
-          <p:cNvPr id="14" name=""/>
+          <p:cNvPr id="16" name=""/>
           <p:cNvSpPr txBox="1"/>
           <p:nvPr/>
         </p:nvSpPr>
         <p:spPr>
           <a:xfrm>
             <a:off x="2152650" y="5343525"/>
-            <a:ext cx="4629150" cy="333375"/>
+            <a:ext cx="7115175" cy="333375"/>
           </a:xfrm>
           <a:prstGeom prst="rect">
             <a:avLst/>
@@ -6919,7 +6897,7 @@
                 <a:latin typeface="Noto Sans JP"/>
                 <a:ea typeface="Noto Sans JP"/>
               </a:rPr>
-              <a:t>「コーヒー1杯」として数えるので </a:t>
+              <a:t>言い方はどれでも○。「コーヒー1杯」として数えるので </a:t>
             </a:r>
             <a:pPr/>
             <a:r>

</xml_diff>

<commit_message>
Keep the practice deck cover in the left two thirds of the slide
Hina appears on the right side of the video, so the cover card now ends
at two thirds of the width, with a slightly smaller title and no tile.

Co-Authored-By: Claude Opus 5.5 <noreply@anthropic.com>
Claude-Session: https://claude.ai/code/session_01AdzV2rtokspoPMcfpFKx4K
</commit_message>
<xml_diff>
--- a/matome/articles-4/articles-4-slides.pptx
+++ b/matome/articles-4/articles-4-slides.pptx
@@ -499,7 +499,7 @@
         <p:spPr>
           <a:xfrm>
             <a:off x="419100" y="419100"/>
-            <a:ext cx="11353800" cy="6019800"/>
+            <a:ext cx="7705725" cy="6019800"/>
           </a:xfrm>
           <a:prstGeom prst="roundRect">
             <a:avLst>
@@ -520,7 +520,7 @@
         </p:nvSpPr>
         <p:spPr>
           <a:xfrm>
-            <a:off x="1181100" y="2047875"/>
+            <a:off x="990600" y="2190750"/>
             <a:ext cx="2076450" cy="304800"/>
           </a:xfrm>
           <a:prstGeom prst="rect">
@@ -555,22 +555,22 @@
         </p:nvSpPr>
         <p:spPr>
           <a:xfrm>
-            <a:off x="1181100" y="2162175"/>
-            <a:ext cx="8248650" cy="2314575"/>
-          </a:xfrm>
-          <a:prstGeom prst="rect">
-            <a:avLst/>
-          </a:prstGeom>
-          <a:noFill/>
-          <a:ln/>
-        </p:spPr>
-        <p:txBody>
-          <a:bodyPr wrap="square" lIns="0" tIns="0" rIns="0" bIns="0" anchor="ctr"/>
-          <a:lstStyle/>
-          <a:p>
-            <a:pPr/>
-            <a:r>
-              <a:rPr sz="12600" b="1">
+            <a:off x="990600" y="2362200"/>
+            <a:ext cx="7267575" cy="1924050"/>
+          </a:xfrm>
+          <a:prstGeom prst="rect">
+            <a:avLst/>
+          </a:prstGeom>
+          <a:noFill/>
+          <a:ln/>
+        </p:spPr>
+        <p:txBody>
+          <a:bodyPr wrap="square" lIns="0" tIns="0" rIns="0" bIns="0" anchor="ctr"/>
+          <a:lstStyle/>
+          <a:p>
+            <a:pPr/>
+            <a:r>
+              <a:rPr sz="10500" b="1">
                 <a:solidFill>
                   <a:srgbClr val="1C2340"/>
                 </a:solidFill>
@@ -581,7 +581,7 @@
             </a:r>
             <a:pPr/>
             <a:r>
-              <a:rPr sz="6900" b="1">
+              <a:rPr sz="6300" b="1">
                 <a:solidFill>
                   <a:srgbClr val="E8461E"/>
                 </a:solidFill>
@@ -601,7 +601,7 @@
         </p:nvSpPr>
         <p:spPr>
           <a:xfrm>
-            <a:off x="1181100" y="4371975"/>
+            <a:off x="990600" y="4229100"/>
             <a:ext cx="6705600" cy="438150"/>
           </a:xfrm>
           <a:prstGeom prst="rect">
@@ -628,30 +628,6 @@
           </a:p>
         </p:txBody>
       </p:sp>
-      <p:pic>
-        <p:nvPicPr>
-          <p:cNvPr id="6" name="Image 0" descr="/home/user/hina-english/matome/img/tile.png">    </p:cNvPr>
-          <p:cNvPicPr>
-            <a:picLocks noChangeAspect="1"/>
-          </p:cNvPicPr>
-          <p:nvPr/>
-        </p:nvPicPr>
-        <p:blipFill>
-          <a:blip r:embed="rId1"/>
-          <a:stretch>
-            <a:fillRect/>
-          </a:stretch>
-        </p:blipFill>
-        <p:spPr>
-          <a:xfrm>
-            <a:off x="7924800" y="1809750"/>
-            <a:ext cx="3238500" cy="3238500"/>
-          </a:xfrm>
-          <a:prstGeom prst="rect">
-            <a:avLst/>
-          </a:prstGeom>
-        </p:spPr>
-      </p:pic>
     </p:spTree>
   </p:cSld>
   <p:clrMapOvr>

</xml_diff>